<commit_message>
Update the review deck with measured results and add a speaking script
Deck changes:
- feedback slide rewritten against the 03 Aug review comments and what was
  done about each
- new slide carrying the measured accuracy: precision, recall, F1 and ring
  recall, the confusion matrix, and the finding that the block band never
  fires, with the synthetic-data caveat stated on the slide rather than
  left for someone to ask about
- challenges slide now records the two defects the benchmark exposed
- conclusion rewritten around evidence instead of claims

The speaking script is a separate Word document, not slide notes, with one
section per slide and seven likely questions with answers.

Fixes a bug in the deck patcher: python-pptx returns a new wrapper object
on each shape access, so an identity comparison against the title
placeholder never matched and the conclusion title was deleted along with
the body shapes. Compare the underlying XML elements instead.
</commit_message>
<xml_diff>
--- a/docs/Indus11-Review2.pptx
+++ b/docs/Indus11-Review2.pptx
@@ -20,6 +20,7 @@
     <p:sldId id="262" r:id="rId14"/>
     <p:sldId id="263" r:id="rId15"/>
     <p:sldId id="264" r:id="rId16"/>
+    <p:sldId id="269" r:id="rId21"/>
     <p:sldId id="265" r:id="rId17"/>
     <p:sldId id="266" r:id="rId18"/>
     <p:sldId id="267" r:id="rId19"/>
@@ -4673,7 +4674,7 @@
               </a:spcAft>
             </a:pPr>
             <a:r>
-              <a:rPr sz="1600" b="1">
+              <a:rPr sz="1500" b="1">
                 <a:solidFill>
                   <a:srgbClr val="B26A00"/>
                 </a:solidFill>
@@ -4689,13 +4690,13 @@
               </a:spcAft>
             </a:pPr>
             <a:r>
-              <a:rPr sz="1400" b="0">
+              <a:rPr sz="1300" b="0">
                 <a:solidFill>
                   <a:srgbClr val="222833"/>
                 </a:solidFill>
                 <a:latin typeface="Cambria"/>
               </a:rPr>
-              <a:t>Coordinating four data stores locally</a:t>
+              <a:t>Coordinating four data stores on one machine</a:t>
             </a:r>
           </a:p>
           <a:p>
@@ -4705,13 +4706,13 @@
               </a:spcAft>
             </a:pPr>
             <a:r>
-              <a:rPr sz="1400" b="0">
+              <a:rPr sz="1300" b="0">
                 <a:solidFill>
                   <a:srgbClr val="222833"/>
                 </a:solidFill>
                 <a:latin typeface="Cambria"/>
               </a:rPr>
-              <a:t>Keeping LLM output consistent — temp 0 + 30-pt cap</a:t>
+              <a:t>Keeping model output consistent — solved with a 30-point cap</a:t>
             </a:r>
           </a:p>
           <a:p>
@@ -4721,13 +4722,13 @@
               </a:spcAft>
             </a:pPr>
             <a:r>
-              <a:rPr sz="1400" b="0">
+              <a:rPr sz="1300" b="0">
                 <a:solidFill>
                   <a:srgbClr val="222833"/>
                 </a:solidFill>
                 <a:latin typeface="Cambria"/>
               </a:rPr>
-              <a:t>Cypher queries for circular money-mule flows</a:t>
+              <a:t>Writing Cypher queries for circular money-mule flows</a:t>
             </a:r>
           </a:p>
           <a:p>
@@ -4737,13 +4738,45 @@
               </a:spcAft>
             </a:pPr>
             <a:r>
-              <a:rPr sz="1400" b="0">
+              <a:rPr sz="1300" b="0">
                 <a:solidFill>
                   <a:srgbClr val="222833"/>
                 </a:solidFill>
                 <a:latin typeface="Cambria"/>
               </a:rPr>
-              <a:t>Migrating data layer MySQL → MongoDB</a:t>
+              <a:t>Two defects the benchmark exposed: a repeated request returned</a:t>
+            </a:r>
+          </a:p>
+          <a:p>
+            <a:pPr lvl="1">
+              <a:spcAft>
+                <a:spcPts val="400"/>
+              </a:spcAft>
+            </a:pPr>
+            <a:r>
+              <a:rPr sz="1300" b="0">
+                <a:solidFill>
+                  <a:srgbClr val="222833"/>
+                </a:solidFill>
+                <a:latin typeface="Cambria"/>
+              </a:rPr>
+              <a:t>a server error, and a parsing fault silently zeroed the AI</a:t>
+            </a:r>
+          </a:p>
+          <a:p>
+            <a:pPr lvl="1">
+              <a:spcAft>
+                <a:spcPts val="400"/>
+              </a:spcAft>
+            </a:pPr>
+            <a:r>
+              <a:rPr sz="1300" b="0">
+                <a:solidFill>
+                  <a:srgbClr val="222833"/>
+                </a:solidFill>
+                <a:latin typeface="Cambria"/>
+              </a:rPr>
+              <a:t>score — both fixed and covered by tests</a:t>
             </a:r>
           </a:p>
         </p:txBody>
@@ -4769,7 +4802,7 @@
               </a:spcAft>
             </a:pPr>
             <a:r>
-              <a:rPr sz="1600" b="1">
+              <a:rPr sz="1500" b="1">
                 <a:solidFill>
                   <a:srgbClr val="2E7D32"/>
                 </a:solidFill>
@@ -4785,13 +4818,13 @@
               </a:spcAft>
             </a:pPr>
             <a:r>
-              <a:rPr sz="1400" b="0">
+              <a:rPr sz="1300" b="0">
                 <a:solidFill>
                   <a:srgbClr val="222833"/>
                 </a:solidFill>
                 <a:latin typeface="Cambria"/>
               </a:rPr>
-              <a:t>Measure accuracy — precision / recall</a:t>
+              <a:t>Resolve the block-threshold trade-off from recorded scores</a:t>
             </a:r>
           </a:p>
           <a:p>
@@ -4801,13 +4834,13 @@
               </a:spcAft>
             </a:pPr>
             <a:r>
-              <a:rPr sz="1400" b="0">
+              <a:rPr sz="1300" b="0">
                 <a:solidFill>
                   <a:srgbClr val="222833"/>
                 </a:solidFill>
                 <a:latin typeface="Cambria"/>
               </a:rPr>
-              <a:t>Train a supervised model as 4th signal</a:t>
+              <a:t>Add API authentication and request logging</a:t>
             </a:r>
           </a:p>
           <a:p>
@@ -4817,13 +4850,13 @@
               </a:spcAft>
             </a:pPr>
             <a:r>
-              <a:rPr sz="1400" b="0">
+              <a:rPr sz="1300" b="0">
                 <a:solidFill>
                   <a:srgbClr val="222833"/>
                 </a:solidFill>
                 <a:latin typeface="Cambria"/>
               </a:rPr>
-              <a:t>Fraud-ring visualisation in the dashboard</a:t>
+              <a:t>Fraud-ring visualisation on the graph endpoint</a:t>
             </a:r>
           </a:p>
           <a:p>
@@ -4833,13 +4866,13 @@
               </a:spcAft>
             </a:pPr>
             <a:r>
-              <a:rPr sz="1400" b="0">
+              <a:rPr sz="1300" b="0">
                 <a:solidFill>
                   <a:srgbClr val="222833"/>
                 </a:solidFill>
                 <a:latin typeface="Cambria"/>
               </a:rPr>
-              <a:t>Harden the API — auth, encryption, load test</a:t>
+              <a:t>Investigate the 7 undetected frauds; fan-in / fan-out patterns</a:t>
             </a:r>
           </a:p>
           <a:p>
@@ -4849,13 +4882,29 @@
               </a:spcAft>
             </a:pPr>
             <a:r>
-              <a:rPr sz="1400" b="0">
+              <a:rPr sz="1300" b="0">
                 <a:solidFill>
                   <a:srgbClr val="222833"/>
                 </a:solidFill>
                 <a:latin typeface="Cambria"/>
               </a:rPr>
-              <a:t>Complete the SRS and final report</a:t>
+              <a:t>Train a supervised classifier as a fourth signal</a:t>
+            </a:r>
+          </a:p>
+          <a:p>
+            <a:pPr lvl="1">
+              <a:spcAft>
+                <a:spcPts val="400"/>
+              </a:spcAft>
+            </a:pPr>
+            <a:r>
+              <a:rPr sz="1300" b="0">
+                <a:solidFill>
+                  <a:srgbClr val="222833"/>
+                </a:solidFill>
+                <a:latin typeface="Cambria"/>
+              </a:rPr>
+              <a:t>Reduce latency, presently dominated by the local model</a:t>
             </a:r>
           </a:p>
         </p:txBody>
@@ -4941,48 +4990,14 @@
       </p:sp>
       <p:sp>
         <p:nvSpPr>
-          <p:cNvPr id="3" name="TextBox 2"/>
-          <p:cNvSpPr txBox="1"/>
+          <p:cNvPr id="3" name="Rounded Rectangle 2"/>
+          <p:cNvSpPr/>
           <p:nvPr/>
         </p:nvSpPr>
         <p:spPr>
           <a:xfrm>
-            <a:off x="18288" y="109728"/>
-            <a:ext cx="8229600" cy="292608"/>
-          </a:xfrm>
-          <a:prstGeom prst="rect">
-            <a:avLst/>
-          </a:prstGeom>
-          <a:noFill/>
-        </p:spPr>
-        <p:txBody>
-          <a:bodyPr wrap="none">
-            <a:spAutoFit/>
-          </a:bodyPr>
-          <a:lstStyle/>
-          <a:p>
-            <a:r>
-              <a:rPr sz="1100" b="1">
-                <a:solidFill>
-                  <a:srgbClr val="028090"/>
-                </a:solidFill>
-                <a:latin typeface="Cambria"/>
-              </a:rPr>
-              <a:t>08 · CONCLUSION</a:t>
-            </a:r>
-          </a:p>
-        </p:txBody>
-      </p:sp>
-      <p:sp>
-        <p:nvSpPr>
-          <p:cNvPr id="4" name="Rounded Rectangle 3"/>
-          <p:cNvSpPr/>
-          <p:nvPr/>
-        </p:nvSpPr>
-        <p:spPr>
-          <a:xfrm>
-            <a:off x="457200" y="1920240"/>
-            <a:ext cx="2743200" cy="2743200"/>
+            <a:off x="457200" y="1828800"/>
+            <a:ext cx="2743200" cy="2834640"/>
           </a:xfrm>
           <a:prstGeom prst="roundRect">
             <a:avLst/>
@@ -4990,7 +5005,7 @@
           <a:solidFill>
             <a:srgbClr val="F4F6FA"/>
           </a:solidFill>
-          <a:ln w="12700">
+          <a:ln>
             <a:solidFill>
               <a:srgbClr val="C7D0DE"/>
             </a:solidFill>
@@ -5012,10 +5027,10 @@
           </a:fontRef>
         </p:style>
         <p:txBody>
-          <a:bodyPr rtlCol="0" anchor="t" wrap="square" lIns="146304" rIns="128016" tIns="182880"/>
-          <a:lstStyle/>
-          <a:p>
-            <a:pPr algn="l">
+          <a:bodyPr rtlCol="0" anchor="ctr" wrap="square" lIns="146304" rIns="128016" tIns="182880"/>
+          <a:lstStyle/>
+          <a:p>
+            <a:pPr algn="ctr">
               <a:spcAft>
                 <a:spcPts val="800"/>
               </a:spcAft>
@@ -5027,13 +5042,13 @@
                 </a:solidFill>
                 <a:latin typeface="Cambria"/>
               </a:rPr>
-              <a:t>A working end-to-end prototype</a:t>
-            </a:r>
-          </a:p>
-          <a:p>
-            <a:pPr algn="l">
+              <a:t>Measured, not asserted</a:t>
+            </a:r>
+          </a:p>
+          <a:p>
+            <a:pPr>
               <a:spcAft>
-                <a:spcPts val="400"/>
+                <a:spcPts val="800"/>
               </a:spcAft>
             </a:pPr>
             <a:r>
@@ -5043,21 +5058,21 @@
                 </a:solidFill>
                 <a:latin typeface="Cambria"/>
               </a:rPr>
-              <a:t>All five layers run together and score real transactions.</a:t>
-            </a:r>
-          </a:p>
-        </p:txBody>
-      </p:sp>
-      <p:sp>
-        <p:nvSpPr>
-          <p:cNvPr id="5" name="Rounded Rectangle 4"/>
+              <a:t>93.8% precision, 86.5% recall, F1 0.90 on 208 labelled transactions.</a:t>
+            </a:r>
+          </a:p>
+        </p:txBody>
+      </p:sp>
+      <p:sp>
+        <p:nvSpPr>
+          <p:cNvPr id="4" name="Rounded Rectangle 3"/>
           <p:cNvSpPr/>
           <p:nvPr/>
         </p:nvSpPr>
         <p:spPr>
           <a:xfrm>
-            <a:off x="3447288" y="1920240"/>
-            <a:ext cx="2743200" cy="2743200"/>
+            <a:off x="3447288" y="1828800"/>
+            <a:ext cx="2743200" cy="2834640"/>
           </a:xfrm>
           <a:prstGeom prst="roundRect">
             <a:avLst/>
@@ -5065,7 +5080,7 @@
           <a:solidFill>
             <a:srgbClr val="F4F6FA"/>
           </a:solidFill>
-          <a:ln w="12700">
+          <a:ln>
             <a:solidFill>
               <a:srgbClr val="C7D0DE"/>
             </a:solidFill>
@@ -5087,10 +5102,10 @@
           </a:fontRef>
         </p:style>
         <p:txBody>
-          <a:bodyPr rtlCol="0" anchor="t" wrap="square" lIns="146304" rIns="128016" tIns="182880"/>
-          <a:lstStyle/>
-          <a:p>
-            <a:pPr algn="l">
+          <a:bodyPr rtlCol="0" anchor="ctr" wrap="square" lIns="146304" rIns="128016" tIns="182880"/>
+          <a:lstStyle/>
+          <a:p>
+            <a:pPr algn="ctr">
               <a:spcAft>
                 <a:spcPts val="800"/>
               </a:spcAft>
@@ -5102,13 +5117,13 @@
                 </a:solidFill>
                 <a:latin typeface="Cambria"/>
               </a:rPr>
-              <a:t>Live dashboard + 12 REST APIs</a:t>
-            </a:r>
-          </a:p>
-          <a:p>
-            <a:pPr algn="l">
+              <a:t>The graph layer earns its place</a:t>
+            </a:r>
+          </a:p>
+          <a:p>
+            <a:pPr>
               <a:spcAft>
-                <a:spcPts val="400"/>
+                <a:spcPts val="800"/>
               </a:spcAft>
             </a:pPr>
             <a:r>
@@ -5118,21 +5133,21 @@
                 </a:solidFill>
                 <a:latin typeface="Cambria"/>
               </a:rPr>
-              <a:t>Analysts see decisions, charts, and flagged transactions in real time.</a:t>
-            </a:r>
-          </a:p>
-        </p:txBody>
-      </p:sp>
-      <p:sp>
-        <p:nvSpPr>
-          <p:cNvPr id="6" name="Rounded Rectangle 5"/>
+              <a:t>All 36 planted mule-ring transactions were detected.</a:t>
+            </a:r>
+          </a:p>
+        </p:txBody>
+      </p:sp>
+      <p:sp>
+        <p:nvSpPr>
+          <p:cNvPr id="5" name="Rounded Rectangle 4"/>
           <p:cNvSpPr/>
           <p:nvPr/>
         </p:nvSpPr>
         <p:spPr>
           <a:xfrm>
-            <a:off x="6437376" y="1920240"/>
-            <a:ext cx="2743200" cy="2743200"/>
+            <a:off x="6437376" y="1828800"/>
+            <a:ext cx="2743200" cy="2834640"/>
           </a:xfrm>
           <a:prstGeom prst="roundRect">
             <a:avLst/>
@@ -5140,7 +5155,7 @@
           <a:solidFill>
             <a:srgbClr val="F4F6FA"/>
           </a:solidFill>
-          <a:ln w="12700">
+          <a:ln>
             <a:solidFill>
               <a:srgbClr val="C7D0DE"/>
             </a:solidFill>
@@ -5162,10 +5177,10 @@
           </a:fontRef>
         </p:style>
         <p:txBody>
-          <a:bodyPr rtlCol="0" anchor="t" wrap="square" lIns="146304" rIns="128016" tIns="182880"/>
-          <a:lstStyle/>
-          <a:p>
-            <a:pPr algn="l">
+          <a:bodyPr rtlCol="0" anchor="ctr" wrap="square" lIns="146304" rIns="128016" tIns="182880"/>
+          <a:lstStyle/>
+          <a:p>
+            <a:pPr algn="ctr">
               <a:spcAft>
                 <a:spcPts val="800"/>
               </a:spcAft>
@@ -5173,17 +5188,17 @@
             <a:r>
               <a:rPr sz="1400" b="1">
                 <a:solidFill>
-                  <a:srgbClr val="2E7D32"/>
-                </a:solidFill>
-                <a:latin typeface="Cambria"/>
-              </a:rPr>
-              <a:t>Graph + AI, explained</a:t>
-            </a:r>
-          </a:p>
-          <a:p>
-            <a:pPr algn="l">
+                  <a:srgbClr val="C62828"/>
+                </a:solidFill>
+                <a:latin typeface="Cambria"/>
+              </a:rPr>
+              <a:t>A finding worth reporting</a:t>
+            </a:r>
+          </a:p>
+          <a:p>
+            <a:pPr>
               <a:spcAft>
-                <a:spcPts val="400"/>
+                <a:spcPts val="800"/>
               </a:spcAft>
             </a:pPr>
             <a:r>
@@ -5193,21 +5208,21 @@
                 </a:solidFill>
                 <a:latin typeface="Cambria"/>
               </a:rPr>
-              <a:t>Fraud rings caught by Neo4j; every decision carries a plain-English reason.</a:t>
-            </a:r>
-          </a:p>
-        </p:txBody>
-      </p:sp>
-      <p:sp>
-        <p:nvSpPr>
-          <p:cNvPr id="7" name="Rounded Rectangle 6"/>
+              <a:t>Nothing reaches the block threshold; every catch reaches an analyst.</a:t>
+            </a:r>
+          </a:p>
+        </p:txBody>
+      </p:sp>
+      <p:sp>
+        <p:nvSpPr>
+          <p:cNvPr id="6" name="Rounded Rectangle 5"/>
           <p:cNvSpPr/>
           <p:nvPr/>
         </p:nvSpPr>
         <p:spPr>
           <a:xfrm>
-            <a:off x="9427464" y="1920240"/>
-            <a:ext cx="2743200" cy="2743200"/>
+            <a:off x="9427464" y="1828800"/>
+            <a:ext cx="2743200" cy="2834640"/>
           </a:xfrm>
           <a:prstGeom prst="roundRect">
             <a:avLst/>
@@ -5215,7 +5230,7 @@
           <a:solidFill>
             <a:srgbClr val="F4F6FA"/>
           </a:solidFill>
-          <a:ln w="12700">
+          <a:ln>
             <a:solidFill>
               <a:srgbClr val="C7D0DE"/>
             </a:solidFill>
@@ -5237,10 +5252,10 @@
           </a:fontRef>
         </p:style>
         <p:txBody>
-          <a:bodyPr rtlCol="0" anchor="t" wrap="square" lIns="146304" rIns="128016" tIns="182880"/>
-          <a:lstStyle/>
-          <a:p>
-            <a:pPr algn="l">
+          <a:bodyPr rtlCol="0" anchor="ctr" wrap="square" lIns="146304" rIns="128016" tIns="182880"/>
+          <a:lstStyle/>
+          <a:p>
+            <a:pPr algn="ctr">
               <a:spcAft>
                 <a:spcPts val="800"/>
               </a:spcAft>
@@ -5248,17 +5263,17 @@
             <a:r>
               <a:rPr sz="1400" b="1">
                 <a:solidFill>
-                  <a:srgbClr val="B26A00"/>
-                </a:solidFill>
-                <a:latin typeface="Cambria"/>
-              </a:rPr>
-              <a:t>On track for next milestones</a:t>
-            </a:r>
-          </a:p>
-          <a:p>
-            <a:pPr algn="l">
+                  <a:srgbClr val="2E7D32"/>
+                </a:solidFill>
+                <a:latin typeface="Cambria"/>
+              </a:rPr>
+              <a:t>Engineering discipline</a:t>
+            </a:r>
+          </a:p>
+          <a:p>
+            <a:pPr>
               <a:spcAft>
-                <a:spcPts val="400"/>
+                <a:spcPts val="800"/>
               </a:spcAft>
             </a:pPr>
             <a:r>
@@ -5268,7 +5283,7 @@
                 </a:solidFill>
                 <a:latin typeface="Cambria"/>
               </a:rPr>
-              <a:t>Next: accuracy metrics, hardening, SRS, and the final report.</a:t>
+              <a:t>27 automated tests, continuous integration, one-command deployment.</a:t>
             </a:r>
           </a:p>
         </p:txBody>
@@ -5542,6 +5557,817 @@
                 <a:latin typeface="Cambria"/>
               </a:rPr>
               <a:t>Joshi Om · Krish Gajera · Drashti Dedaniya  —  CHARUSAT · DEPSTAR</a:t>
+            </a:r>
+          </a:p>
+        </p:txBody>
+      </p:sp>
+    </p:spTree>
+  </p:cSld>
+  <p:clrMapOvr>
+    <a:masterClrMapping/>
+  </p:clrMapOvr>
+</p:sld>
+</file>
+
+<file path=ppt/slides/slide14.xml><?xml version="1.0" encoding="utf-8"?>
+<p:sld xmlns:a="http://schemas.openxmlformats.org/drawingml/2006/main" xmlns:p="http://schemas.openxmlformats.org/presentationml/2006/main" xmlns:r="http://schemas.openxmlformats.org/officeDocument/2006/relationships">
+  <p:cSld>
+    <p:spTree>
+      <p:nvGrpSpPr>
+        <p:cNvPr id="1" name=""/>
+        <p:cNvGrpSpPr/>
+        <p:nvPr/>
+      </p:nvGrpSpPr>
+      <p:grpSpPr/>
+      <p:sp>
+        <p:nvSpPr>
+          <p:cNvPr id="2" name="Title 1"/>
+          <p:cNvSpPr>
+            <a:spLocks noGrp="1"/>
+          </p:cNvSpPr>
+          <p:nvPr>
+            <p:ph type="title"/>
+          </p:nvPr>
+        </p:nvSpPr>
+        <p:spPr/>
+        <p:txBody>
+          <a:bodyPr/>
+          <a:lstStyle/>
+          <a:p>
+            <a:r>
+              <a:rPr sz="2800" b="1">
+                <a:solidFill>
+                  <a:srgbClr val="002060"/>
+                </a:solidFill>
+                <a:latin typeface="Cambria"/>
+              </a:rPr>
+              <a:t>Detection Accuracy — Measured Results</a:t>
+            </a:r>
+          </a:p>
+        </p:txBody>
+      </p:sp>
+      <p:sp>
+        <p:nvSpPr>
+          <p:cNvPr id="3" name="TextBox 2"/>
+          <p:cNvSpPr txBox="1"/>
+          <p:nvPr/>
+        </p:nvSpPr>
+        <p:spPr>
+          <a:xfrm>
+            <a:off x="502920" y="1298448"/>
+            <a:ext cx="11155680" cy="365760"/>
+          </a:xfrm>
+          <a:prstGeom prst="rect">
+            <a:avLst/>
+          </a:prstGeom>
+          <a:noFill/>
+        </p:spPr>
+        <p:txBody>
+          <a:bodyPr wrap="none">
+            <a:spAutoFit/>
+          </a:bodyPr>
+          <a:lstStyle/>
+          <a:p>
+            <a:r>
+              <a:rPr sz="1400">
+                <a:solidFill>
+                  <a:srgbClr val="555B66"/>
+                </a:solidFill>
+                <a:latin typeface="Cambria"/>
+              </a:rPr>
+              <a:t>208 labelled synthetic transactions — 52 fraudulent, 156 legitimate — replayed through the complete pipeline</a:t>
+            </a:r>
+          </a:p>
+        </p:txBody>
+      </p:sp>
+      <p:sp>
+        <p:nvSpPr>
+          <p:cNvPr id="4" name="Rounded Rectangle 3"/>
+          <p:cNvSpPr/>
+          <p:nvPr/>
+        </p:nvSpPr>
+        <p:spPr>
+          <a:xfrm>
+            <a:off x="502920" y="1783080"/>
+            <a:ext cx="2697480" cy="1417320"/>
+          </a:xfrm>
+          <a:prstGeom prst="roundRect">
+            <a:avLst/>
+          </a:prstGeom>
+          <a:solidFill>
+            <a:srgbClr val="F4F6FA"/>
+          </a:solidFill>
+          <a:ln>
+            <a:solidFill>
+              <a:srgbClr val="C7D0DE"/>
+            </a:solidFill>
+          </a:ln>
+          <a:effectLst/>
+        </p:spPr>
+        <p:style>
+          <a:lnRef idx="1">
+            <a:schemeClr val="accent1"/>
+          </a:lnRef>
+          <a:fillRef idx="3">
+            <a:schemeClr val="accent1"/>
+          </a:fillRef>
+          <a:effectRef idx="2">
+            <a:schemeClr val="accent1"/>
+          </a:effectRef>
+          <a:fontRef idx="minor">
+            <a:schemeClr val="lt1"/>
+          </a:fontRef>
+        </p:style>
+        <p:txBody>
+          <a:bodyPr rtlCol="0" anchor="ctr" wrap="square" tIns="109728"/>
+          <a:lstStyle/>
+          <a:p>
+            <a:pPr algn="ctr">
+              <a:spcAft>
+                <a:spcPts val="100"/>
+              </a:spcAft>
+            </a:pPr>
+            <a:r>
+              <a:rPr sz="3000" b="1">
+                <a:solidFill>
+                  <a:srgbClr val="2E7D32"/>
+                </a:solidFill>
+                <a:latin typeface="Cambria"/>
+              </a:rPr>
+              <a:t>93.8%</a:t>
+            </a:r>
+          </a:p>
+          <a:p>
+            <a:pPr algn="ctr">
+              <a:spcAft>
+                <a:spcPts val="100"/>
+              </a:spcAft>
+            </a:pPr>
+            <a:r>
+              <a:rPr sz="1300" b="1">
+                <a:solidFill>
+                  <a:srgbClr val="002060"/>
+                </a:solidFill>
+                <a:latin typeface="Cambria"/>
+              </a:rPr>
+              <a:t>Precision</a:t>
+            </a:r>
+          </a:p>
+          <a:p>
+            <a:pPr algn="ctr">
+              <a:spcAft>
+                <a:spcPts val="100"/>
+              </a:spcAft>
+            </a:pPr>
+            <a:r>
+              <a:rPr sz="1050" b="0">
+                <a:solidFill>
+                  <a:srgbClr val="555B66"/>
+                </a:solidFill>
+                <a:latin typeface="Cambria"/>
+              </a:rPr>
+              <a:t>of flagged were fraud</a:t>
+            </a:r>
+          </a:p>
+        </p:txBody>
+      </p:sp>
+      <p:sp>
+        <p:nvSpPr>
+          <p:cNvPr id="5" name="Rounded Rectangle 4"/>
+          <p:cNvSpPr/>
+          <p:nvPr/>
+        </p:nvSpPr>
+        <p:spPr>
+          <a:xfrm>
+            <a:off x="3337560" y="1783080"/>
+            <a:ext cx="2697480" cy="1417320"/>
+          </a:xfrm>
+          <a:prstGeom prst="roundRect">
+            <a:avLst/>
+          </a:prstGeom>
+          <a:solidFill>
+            <a:srgbClr val="F4F6FA"/>
+          </a:solidFill>
+          <a:ln>
+            <a:solidFill>
+              <a:srgbClr val="C7D0DE"/>
+            </a:solidFill>
+          </a:ln>
+          <a:effectLst/>
+        </p:spPr>
+        <p:style>
+          <a:lnRef idx="1">
+            <a:schemeClr val="accent1"/>
+          </a:lnRef>
+          <a:fillRef idx="3">
+            <a:schemeClr val="accent1"/>
+          </a:fillRef>
+          <a:effectRef idx="2">
+            <a:schemeClr val="accent1"/>
+          </a:effectRef>
+          <a:fontRef idx="minor">
+            <a:schemeClr val="lt1"/>
+          </a:fontRef>
+        </p:style>
+        <p:txBody>
+          <a:bodyPr rtlCol="0" anchor="ctr" wrap="square" tIns="109728"/>
+          <a:lstStyle/>
+          <a:p>
+            <a:pPr algn="ctr">
+              <a:spcAft>
+                <a:spcPts val="100"/>
+              </a:spcAft>
+            </a:pPr>
+            <a:r>
+              <a:rPr sz="3000" b="1">
+                <a:solidFill>
+                  <a:srgbClr val="028090"/>
+                </a:solidFill>
+                <a:latin typeface="Cambria"/>
+              </a:rPr>
+              <a:t>86.5%</a:t>
+            </a:r>
+          </a:p>
+          <a:p>
+            <a:pPr algn="ctr">
+              <a:spcAft>
+                <a:spcPts val="100"/>
+              </a:spcAft>
+            </a:pPr>
+            <a:r>
+              <a:rPr sz="1300" b="1">
+                <a:solidFill>
+                  <a:srgbClr val="002060"/>
+                </a:solidFill>
+                <a:latin typeface="Cambria"/>
+              </a:rPr>
+              <a:t>Recall</a:t>
+            </a:r>
+          </a:p>
+          <a:p>
+            <a:pPr algn="ctr">
+              <a:spcAft>
+                <a:spcPts val="100"/>
+              </a:spcAft>
+            </a:pPr>
+            <a:r>
+              <a:rPr sz="1050" b="0">
+                <a:solidFill>
+                  <a:srgbClr val="555B66"/>
+                </a:solidFill>
+                <a:latin typeface="Cambria"/>
+              </a:rPr>
+              <a:t>of fraud was caught</a:t>
+            </a:r>
+          </a:p>
+        </p:txBody>
+      </p:sp>
+      <p:sp>
+        <p:nvSpPr>
+          <p:cNvPr id="6" name="Rounded Rectangle 5"/>
+          <p:cNvSpPr/>
+          <p:nvPr/>
+        </p:nvSpPr>
+        <p:spPr>
+          <a:xfrm>
+            <a:off x="6172200" y="1783080"/>
+            <a:ext cx="2697480" cy="1417320"/>
+          </a:xfrm>
+          <a:prstGeom prst="roundRect">
+            <a:avLst/>
+          </a:prstGeom>
+          <a:solidFill>
+            <a:srgbClr val="F4F6FA"/>
+          </a:solidFill>
+          <a:ln>
+            <a:solidFill>
+              <a:srgbClr val="C7D0DE"/>
+            </a:solidFill>
+          </a:ln>
+          <a:effectLst/>
+        </p:spPr>
+        <p:style>
+          <a:lnRef idx="1">
+            <a:schemeClr val="accent1"/>
+          </a:lnRef>
+          <a:fillRef idx="3">
+            <a:schemeClr val="accent1"/>
+          </a:fillRef>
+          <a:effectRef idx="2">
+            <a:schemeClr val="accent1"/>
+          </a:effectRef>
+          <a:fontRef idx="minor">
+            <a:schemeClr val="lt1"/>
+          </a:fontRef>
+        </p:style>
+        <p:txBody>
+          <a:bodyPr rtlCol="0" anchor="ctr" wrap="square" tIns="109728"/>
+          <a:lstStyle/>
+          <a:p>
+            <a:pPr algn="ctr">
+              <a:spcAft>
+                <a:spcPts val="100"/>
+              </a:spcAft>
+            </a:pPr>
+            <a:r>
+              <a:rPr sz="3000" b="1">
+                <a:solidFill>
+                  <a:srgbClr val="002060"/>
+                </a:solidFill>
+                <a:latin typeface="Cambria"/>
+              </a:rPr>
+              <a:t>0.90</a:t>
+            </a:r>
+          </a:p>
+          <a:p>
+            <a:pPr algn="ctr">
+              <a:spcAft>
+                <a:spcPts val="100"/>
+              </a:spcAft>
+            </a:pPr>
+            <a:r>
+              <a:rPr sz="1300" b="1">
+                <a:solidFill>
+                  <a:srgbClr val="002060"/>
+                </a:solidFill>
+                <a:latin typeface="Cambria"/>
+              </a:rPr>
+              <a:t>F1 score</a:t>
+            </a:r>
+          </a:p>
+          <a:p>
+            <a:pPr algn="ctr">
+              <a:spcAft>
+                <a:spcPts val="100"/>
+              </a:spcAft>
+            </a:pPr>
+            <a:r>
+              <a:rPr sz="1050" b="0">
+                <a:solidFill>
+                  <a:srgbClr val="555B66"/>
+                </a:solidFill>
+                <a:latin typeface="Cambria"/>
+              </a:rPr>
+              <a:t>combined measure</a:t>
+            </a:r>
+          </a:p>
+        </p:txBody>
+      </p:sp>
+      <p:sp>
+        <p:nvSpPr>
+          <p:cNvPr id="7" name="Rounded Rectangle 6"/>
+          <p:cNvSpPr/>
+          <p:nvPr/>
+        </p:nvSpPr>
+        <p:spPr>
+          <a:xfrm>
+            <a:off x="9006840" y="1783080"/>
+            <a:ext cx="2697480" cy="1417320"/>
+          </a:xfrm>
+          <a:prstGeom prst="roundRect">
+            <a:avLst/>
+          </a:prstGeom>
+          <a:solidFill>
+            <a:srgbClr val="F4F6FA"/>
+          </a:solidFill>
+          <a:ln>
+            <a:solidFill>
+              <a:srgbClr val="C7D0DE"/>
+            </a:solidFill>
+          </a:ln>
+          <a:effectLst/>
+        </p:spPr>
+        <p:style>
+          <a:lnRef idx="1">
+            <a:schemeClr val="accent1"/>
+          </a:lnRef>
+          <a:fillRef idx="3">
+            <a:schemeClr val="accent1"/>
+          </a:fillRef>
+          <a:effectRef idx="2">
+            <a:schemeClr val="accent1"/>
+          </a:effectRef>
+          <a:fontRef idx="minor">
+            <a:schemeClr val="lt1"/>
+          </a:fontRef>
+        </p:style>
+        <p:txBody>
+          <a:bodyPr rtlCol="0" anchor="ctr" wrap="square" tIns="109728"/>
+          <a:lstStyle/>
+          <a:p>
+            <a:pPr algn="ctr">
+              <a:spcAft>
+                <a:spcPts val="100"/>
+              </a:spcAft>
+            </a:pPr>
+            <a:r>
+              <a:rPr sz="3000" b="1">
+                <a:solidFill>
+                  <a:srgbClr val="2E7D32"/>
+                </a:solidFill>
+                <a:latin typeface="Cambria"/>
+              </a:rPr>
+              <a:t>36/36</a:t>
+            </a:r>
+          </a:p>
+          <a:p>
+            <a:pPr algn="ctr">
+              <a:spcAft>
+                <a:spcPts val="100"/>
+              </a:spcAft>
+            </a:pPr>
+            <a:r>
+              <a:rPr sz="1300" b="1">
+                <a:solidFill>
+                  <a:srgbClr val="002060"/>
+                </a:solidFill>
+                <a:latin typeface="Cambria"/>
+              </a:rPr>
+              <a:t>Ring recall</a:t>
+            </a:r>
+          </a:p>
+          <a:p>
+            <a:pPr algn="ctr">
+              <a:spcAft>
+                <a:spcPts val="100"/>
+              </a:spcAft>
+            </a:pPr>
+            <a:r>
+              <a:rPr sz="1050" b="0">
+                <a:solidFill>
+                  <a:srgbClr val="555B66"/>
+                </a:solidFill>
+                <a:latin typeface="Cambria"/>
+              </a:rPr>
+              <a:t>mule-ring hops detected</a:t>
+            </a:r>
+          </a:p>
+        </p:txBody>
+      </p:sp>
+      <p:graphicFrame>
+        <p:nvGraphicFramePr>
+          <p:cNvPr id="8" name="Table 7"/>
+          <p:cNvGraphicFramePr>
+            <a:graphicFrameLocks noGrp="1"/>
+          </p:cNvGraphicFramePr>
+          <p:nvPr/>
+        </p:nvGraphicFramePr>
+        <p:xfrm>
+          <a:off x="502920" y="3337560"/>
+          <a:ext cx="5577840" cy="1737360"/>
+        </p:xfrm>
+        <a:graphic>
+          <a:graphicData uri="http://schemas.openxmlformats.org/drawingml/2006/table">
+            <a:tbl>
+              <a:tblPr firstRow="1" bandRow="1">
+                <a:tableStyleId>{5C22544A-7EE6-4342-B048-85BDC9FD1C3A}</a:tableStyleId>
+              </a:tblPr>
+              <a:tblGrid>
+                <a:gridCol w="1859280"/>
+                <a:gridCol w="1859280"/>
+                <a:gridCol w="1859280"/>
+              </a:tblGrid>
+              <a:tr h="434340">
+                <a:tc>
+                  <a:txBody>
+                    <a:bodyPr/>
+                    <a:lstStyle/>
+                    <a:p>
+                      <a:r>
+                        <a:rPr sz="1200" b="1">
+                          <a:solidFill>
+                            <a:srgbClr val="FFFFFF"/>
+                          </a:solidFill>
+                          <a:latin typeface="Cambria"/>
+                        </a:rPr>
+                        <a:t>Decision</a:t>
+                      </a:r>
+                    </a:p>
+                  </a:txBody>
+                  <a:tcPr>
+                    <a:solidFill>
+                      <a:srgbClr val="002060"/>
+                    </a:solidFill>
+                  </a:tcPr>
+                </a:tc>
+                <a:tc>
+                  <a:txBody>
+                    <a:bodyPr/>
+                    <a:lstStyle/>
+                    <a:p>
+                      <a:r>
+                        <a:rPr sz="1200" b="1">
+                          <a:solidFill>
+                            <a:srgbClr val="FFFFFF"/>
+                          </a:solidFill>
+                          <a:latin typeface="Cambria"/>
+                        </a:rPr>
+                        <a:t>Actually fraud</a:t>
+                      </a:r>
+                    </a:p>
+                  </a:txBody>
+                  <a:tcPr>
+                    <a:solidFill>
+                      <a:srgbClr val="002060"/>
+                    </a:solidFill>
+                  </a:tcPr>
+                </a:tc>
+                <a:tc>
+                  <a:txBody>
+                    <a:bodyPr/>
+                    <a:lstStyle/>
+                    <a:p>
+                      <a:r>
+                        <a:rPr sz="1200" b="1">
+                          <a:solidFill>
+                            <a:srgbClr val="FFFFFF"/>
+                          </a:solidFill>
+                          <a:latin typeface="Cambria"/>
+                        </a:rPr>
+                        <a:t>Actually legitimate</a:t>
+                      </a:r>
+                    </a:p>
+                  </a:txBody>
+                  <a:tcPr>
+                    <a:solidFill>
+                      <a:srgbClr val="002060"/>
+                    </a:solidFill>
+                  </a:tcPr>
+                </a:tc>
+              </a:tr>
+              <a:tr h="434340">
+                <a:tc>
+                  <a:txBody>
+                    <a:bodyPr/>
+                    <a:lstStyle/>
+                    <a:p>
+                      <a:r>
+                        <a:rPr sz="1200" b="0">
+                          <a:solidFill>
+                            <a:srgbClr val="222833"/>
+                          </a:solidFill>
+                          <a:latin typeface="Cambria"/>
+                        </a:rPr>
+                        <a:t>APPROVE</a:t>
+                      </a:r>
+                    </a:p>
+                  </a:txBody>
+                  <a:tcPr/>
+                </a:tc>
+                <a:tc>
+                  <a:txBody>
+                    <a:bodyPr/>
+                    <a:lstStyle/>
+                    <a:p>
+                      <a:r>
+                        <a:rPr sz="1200" b="0">
+                          <a:solidFill>
+                            <a:srgbClr val="222833"/>
+                          </a:solidFill>
+                          <a:latin typeface="Cambria"/>
+                        </a:rPr>
+                        <a:t>7</a:t>
+                      </a:r>
+                    </a:p>
+                  </a:txBody>
+                  <a:tcPr/>
+                </a:tc>
+                <a:tc>
+                  <a:txBody>
+                    <a:bodyPr/>
+                    <a:lstStyle/>
+                    <a:p>
+                      <a:r>
+                        <a:rPr sz="1200" b="0">
+                          <a:solidFill>
+                            <a:srgbClr val="222833"/>
+                          </a:solidFill>
+                          <a:latin typeface="Cambria"/>
+                        </a:rPr>
+                        <a:t>153</a:t>
+                      </a:r>
+                    </a:p>
+                  </a:txBody>
+                  <a:tcPr/>
+                </a:tc>
+              </a:tr>
+              <a:tr h="434340">
+                <a:tc>
+                  <a:txBody>
+                    <a:bodyPr/>
+                    <a:lstStyle/>
+                    <a:p>
+                      <a:r>
+                        <a:rPr sz="1200" b="0">
+                          <a:solidFill>
+                            <a:srgbClr val="222833"/>
+                          </a:solidFill>
+                          <a:latin typeface="Cambria"/>
+                        </a:rPr>
+                        <a:t>REVIEW</a:t>
+                      </a:r>
+                    </a:p>
+                  </a:txBody>
+                  <a:tcPr/>
+                </a:tc>
+                <a:tc>
+                  <a:txBody>
+                    <a:bodyPr/>
+                    <a:lstStyle/>
+                    <a:p>
+                      <a:r>
+                        <a:rPr sz="1200" b="0">
+                          <a:solidFill>
+                            <a:srgbClr val="222833"/>
+                          </a:solidFill>
+                          <a:latin typeface="Cambria"/>
+                        </a:rPr>
+                        <a:t>45</a:t>
+                      </a:r>
+                    </a:p>
+                  </a:txBody>
+                  <a:tcPr/>
+                </a:tc>
+                <a:tc>
+                  <a:txBody>
+                    <a:bodyPr/>
+                    <a:lstStyle/>
+                    <a:p>
+                      <a:r>
+                        <a:rPr sz="1200" b="0">
+                          <a:solidFill>
+                            <a:srgbClr val="222833"/>
+                          </a:solidFill>
+                          <a:latin typeface="Cambria"/>
+                        </a:rPr>
+                        <a:t>3</a:t>
+                      </a:r>
+                    </a:p>
+                  </a:txBody>
+                  <a:tcPr/>
+                </a:tc>
+              </a:tr>
+              <a:tr h="434340">
+                <a:tc>
+                  <a:txBody>
+                    <a:bodyPr/>
+                    <a:lstStyle/>
+                    <a:p>
+                      <a:r>
+                        <a:rPr sz="1200" b="0">
+                          <a:solidFill>
+                            <a:srgbClr val="222833"/>
+                          </a:solidFill>
+                          <a:latin typeface="Cambria"/>
+                        </a:rPr>
+                        <a:t>BLOCK</a:t>
+                      </a:r>
+                    </a:p>
+                  </a:txBody>
+                  <a:tcPr/>
+                </a:tc>
+                <a:tc>
+                  <a:txBody>
+                    <a:bodyPr/>
+                    <a:lstStyle/>
+                    <a:p>
+                      <a:r>
+                        <a:rPr sz="1200" b="0">
+                          <a:solidFill>
+                            <a:srgbClr val="222833"/>
+                          </a:solidFill>
+                          <a:latin typeface="Cambria"/>
+                        </a:rPr>
+                        <a:t>0</a:t>
+                      </a:r>
+                    </a:p>
+                  </a:txBody>
+                  <a:tcPr/>
+                </a:tc>
+                <a:tc>
+                  <a:txBody>
+                    <a:bodyPr/>
+                    <a:lstStyle/>
+                    <a:p>
+                      <a:r>
+                        <a:rPr sz="1200" b="0">
+                          <a:solidFill>
+                            <a:srgbClr val="222833"/>
+                          </a:solidFill>
+                          <a:latin typeface="Cambria"/>
+                        </a:rPr>
+                        <a:t>0</a:t>
+                      </a:r>
+                    </a:p>
+                  </a:txBody>
+                  <a:tcPr/>
+                </a:tc>
+              </a:tr>
+            </a:tbl>
+          </a:graphicData>
+        </a:graphic>
+      </p:graphicFrame>
+      <p:sp>
+        <p:nvSpPr>
+          <p:cNvPr id="9" name="TextBox 8"/>
+          <p:cNvSpPr txBox="1"/>
+          <p:nvPr/>
+        </p:nvSpPr>
+        <p:spPr>
+          <a:xfrm>
+            <a:off x="6400800" y="3337560"/>
+            <a:ext cx="5303520" cy="2194560"/>
+          </a:xfrm>
+          <a:prstGeom prst="rect">
+            <a:avLst/>
+          </a:prstGeom>
+          <a:noFill/>
+        </p:spPr>
+        <p:txBody>
+          <a:bodyPr wrap="square">
+            <a:spAutoFit/>
+          </a:bodyPr>
+          <a:lstStyle/>
+          <a:p>
+            <a:pPr>
+              <a:spcAft>
+                <a:spcPts val="600"/>
+              </a:spcAft>
+            </a:pPr>
+            <a:r>
+              <a:rPr sz="1500" b="1">
+                <a:solidFill>
+                  <a:srgbClr val="C62828"/>
+                </a:solidFill>
+                <a:latin typeface="Cambria"/>
+              </a:rPr>
+              <a:t>Key finding</a:t>
+            </a:r>
+          </a:p>
+          <a:p>
+            <a:pPr>
+              <a:spcAft>
+                <a:spcPts val="600"/>
+              </a:spcAft>
+            </a:pPr>
+            <a:r>
+              <a:rPr sz="1350" b="1">
+                <a:solidFill>
+                  <a:srgbClr val="222833"/>
+                </a:solidFill>
+                <a:latin typeface="Cambria"/>
+              </a:rPr>
+              <a:t>No transaction reached the block threshold of 70.</a:t>
+            </a:r>
+          </a:p>
+          <a:p>
+            <a:pPr>
+              <a:spcAft>
+                <a:spcPts val="600"/>
+              </a:spcAft>
+            </a:pPr>
+            <a:r>
+              <a:rPr sz="1250" b="0">
+                <a:solidFill>
+                  <a:srgbClr val="555B66"/>
+                </a:solidFill>
+                <a:latin typeface="Cambria"/>
+              </a:rPr>
+              <a:t>Every detection is routed to a human analyst; nothing is blocked automatically. Lowering the band would automate blocking — but would also auto-block the three false positives. That is a policy decision, not a configuration change.</a:t>
+            </a:r>
+          </a:p>
+        </p:txBody>
+      </p:sp>
+      <p:sp>
+        <p:nvSpPr>
+          <p:cNvPr id="10" name="TextBox 9"/>
+          <p:cNvSpPr txBox="1"/>
+          <p:nvPr/>
+        </p:nvSpPr>
+        <p:spPr>
+          <a:xfrm>
+            <a:off x="502920" y="5303520"/>
+            <a:ext cx="11155680" cy="548640"/>
+          </a:xfrm>
+          <a:prstGeom prst="rect">
+            <a:avLst/>
+          </a:prstGeom>
+          <a:noFill/>
+        </p:spPr>
+        <p:txBody>
+          <a:bodyPr wrap="square">
+            <a:spAutoFit/>
+          </a:bodyPr>
+          <a:lstStyle/>
+          <a:p>
+            <a:r>
+              <a:rPr sz="1150" i="1">
+                <a:solidFill>
+                  <a:srgbClr val="555B66"/>
+                </a:solidFill>
+                <a:latin typeface="Cambria"/>
+              </a:rPr>
+              <a:t>Measured on synthetic data in which fraud is far denser than a real payment feed, so precision here is optimistic — it measures the separation between the engines, not production performance.</a:t>
             </a:r>
           </a:p>
         </p:txBody>
@@ -5893,7 +6719,7 @@
                 </a:solidFill>
                 <a:latin typeface="Cambria"/>
               </a:rPr>
-              <a:t>Mentor Feedback &amp; Improvements</a:t>
+              <a:t>Guide Feedback &amp; Improvements</a:t>
             </a:r>
           </a:p>
         </p:txBody>
@@ -5919,7 +6745,7 @@
               </a:spcAft>
             </a:pPr>
             <a:r>
-              <a:rPr sz="1600" b="1">
+              <a:rPr sz="1500" b="1">
                 <a:solidFill>
                   <a:srgbClr val="002060"/>
                 </a:solidFill>
@@ -5935,13 +6761,13 @@
               </a:spcAft>
             </a:pPr>
             <a:r>
-              <a:rPr sz="1400" b="0">
+              <a:rPr sz="1300" b="0">
                 <a:solidFill>
                   <a:srgbClr val="222833"/>
                 </a:solidFill>
                 <a:latin typeface="Cambria"/>
               </a:rPr>
-              <a:t>Show real technical progress, not just the idea</a:t>
+              <a:t>Show measured evidence, not just a working demo</a:t>
             </a:r>
           </a:p>
           <a:p>
@@ -5951,13 +6777,13 @@
               </a:spcAft>
             </a:pPr>
             <a:r>
-              <a:rPr sz="1400" b="0">
+              <a:rPr sz="1300" b="0">
                 <a:solidFill>
                   <a:srgbClr val="222833"/>
                 </a:solidFill>
                 <a:latin typeface="Cambria"/>
               </a:rPr>
-              <a:t>Present a concrete architecture &amp; module design</a:t>
+              <a:t>SRS: correct DFD notation and UML diagrams</a:t>
             </a:r>
           </a:p>
           <a:p>
@@ -5967,13 +6793,13 @@
               </a:spcAft>
             </a:pPr>
             <a:r>
-              <a:rPr sz="1400" b="0">
+              <a:rPr sz="1300" b="0">
                 <a:solidFill>
                   <a:srgbClr val="222833"/>
                 </a:solidFill>
                 <a:latin typeface="Cambria"/>
               </a:rPr>
-              <a:t>Add a process-flow / data-flow diagram</a:t>
+              <a:t>Single spacing; each chapter on a new page</a:t>
             </a:r>
           </a:p>
           <a:p>
@@ -5983,13 +6809,13 @@
               </a:spcAft>
             </a:pPr>
             <a:r>
-              <a:rPr sz="1400" b="0">
+              <a:rPr sz="1300" b="0">
                 <a:solidFill>
                   <a:srgbClr val="222833"/>
                 </a:solidFill>
                 <a:latin typeface="Cambria"/>
               </a:rPr>
-              <a:t>Compare existing solutions (literature review)</a:t>
+              <a:t>Conclusion, References, Definitions last, unnumbered</a:t>
             </a:r>
           </a:p>
           <a:p>
@@ -5999,13 +6825,13 @@
               </a:spcAft>
             </a:pPr>
             <a:r>
-              <a:rPr sz="1400" b="0">
+              <a:rPr sz="1300" b="0">
                 <a:solidFill>
                   <a:srgbClr val="222833"/>
                 </a:solidFill>
                 <a:latin typeface="Cambria"/>
               </a:rPr>
-              <a:t>Provide implementation evidence — code, screenshots</a:t>
+              <a:t>Abstract must be written by the team</a:t>
             </a:r>
           </a:p>
           <a:p>
@@ -6015,13 +6841,13 @@
               </a:spcAft>
             </a:pPr>
             <a:r>
-              <a:rPr sz="1400" b="0">
+              <a:rPr sz="1300" b="0">
                 <a:solidFill>
                   <a:srgbClr val="222833"/>
                 </a:solidFill>
                 <a:latin typeface="Cambria"/>
               </a:rPr>
-              <a:t>Set up GitHub with team + mentor as collaborators</a:t>
+              <a:t>Keep the repository updated for review</a:t>
             </a:r>
           </a:p>
         </p:txBody>
@@ -6047,13 +6873,13 @@
               </a:spcAft>
             </a:pPr>
             <a:r>
-              <a:rPr sz="1600" b="1">
+              <a:rPr sz="1500" b="1">
                 <a:solidFill>
                   <a:srgbClr val="2E7D32"/>
                 </a:solidFill>
                 <a:latin typeface="Cambria"/>
               </a:rPr>
-              <a:t>Improvements made</a:t>
+              <a:t>Action taken</a:t>
             </a:r>
           </a:p>
           <a:p>
@@ -6063,13 +6889,13 @@
               </a:spcAft>
             </a:pPr>
             <a:r>
-              <a:rPr sz="1400" b="0">
+              <a:rPr sz="1300" b="0">
                 <a:solidFill>
                   <a:srgbClr val="222833"/>
                 </a:solidFill>
                 <a:latin typeface="Cambria"/>
               </a:rPr>
-              <a:t>Concept → running end-to-end prototype</a:t>
+              <a:t>Built an evaluation harness; results in this deck</a:t>
             </a:r>
           </a:p>
           <a:p>
@@ -6079,13 +6905,13 @@
               </a:spcAft>
             </a:pPr>
             <a:r>
-              <a:rPr sz="1400" b="0">
+              <a:rPr sz="1300" b="0">
                 <a:solidFill>
                   <a:srgbClr val="222833"/>
                 </a:solidFill>
                 <a:latin typeface="Cambria"/>
               </a:rPr>
-              <a:t>Documented 5-layer architecture + interactions</a:t>
+              <a:t>DFDs redrawn in Gane-Sarson notation; 7 UML diagrams</a:t>
             </a:r>
           </a:p>
           <a:p>
@@ -6095,13 +6921,13 @@
               </a:spcAft>
             </a:pPr>
             <a:r>
-              <a:rPr sz="1400" b="0">
+              <a:rPr sz="1300" b="0">
                 <a:solidFill>
                   <a:srgbClr val="222833"/>
                 </a:solidFill>
                 <a:latin typeface="Cambria"/>
               </a:rPr>
-              <a:t>Added step-by-step DFD of the pipeline</a:t>
+              <a:t>Document reformatted to the prescribed style</a:t>
             </a:r>
           </a:p>
           <a:p>
@@ -6111,13 +6937,13 @@
               </a:spcAft>
             </a:pPr>
             <a:r>
-              <a:rPr sz="1400" b="0">
+              <a:rPr sz="1300" b="0">
                 <a:solidFill>
                   <a:srgbClr val="222833"/>
                 </a:solidFill>
                 <a:latin typeface="Cambria"/>
               </a:rPr>
-              <a:t>Built comparison of commercial systems + research</a:t>
+              <a:t>Sections reordered as instructed</a:t>
             </a:r>
           </a:p>
           <a:p>
@@ -6127,13 +6953,13 @@
               </a:spcAft>
             </a:pPr>
             <a:r>
-              <a:rPr sz="1400" b="0">
+              <a:rPr sz="1300" b="0">
                 <a:solidFill>
                   <a:srgbClr val="222833"/>
                 </a:solidFill>
                 <a:latin typeface="Cambria"/>
               </a:rPr>
-              <a:t>Live dashboard + 12 REST APIs on real data</a:t>
+              <a:t>Abstract being written by the team</a:t>
             </a:r>
           </a:p>
           <a:p>
@@ -6143,13 +6969,13 @@
               </a:spcAft>
             </a:pPr>
             <a:r>
-              <a:rPr sz="1400" b="0">
+              <a:rPr sz="1300" b="0">
                 <a:solidFill>
                   <a:srgbClr val="222833"/>
                 </a:solidFill>
                 <a:latin typeface="Cambria"/>
               </a:rPr>
-              <a:t>Repository organised with structured commits</a:t>
+              <a:t>Repository public with continuous integration</a:t>
             </a:r>
           </a:p>
         </p:txBody>

</xml_diff>